<commit_message>
Correction de la numérotation
</commit_message>
<xml_diff>
--- a/Presentation.pptx
+++ b/Presentation.pptx
@@ -4944,7 +4944,7 @@
                   <a:schemeClr val="bg1"/>
                 </a:solidFill>
               </a:rPr>
-              <a:t>1</a:t>
+              <a:t>9</a:t>
             </a:r>
           </a:p>
         </p:txBody>
@@ -6300,8 +6300,8 @@
         </p:nvSpPr>
         <p:spPr>
           <a:xfrm>
-            <a:off x="11644828" y="6286712"/>
-            <a:ext cx="301686" cy="369332"/>
+            <a:off x="11579333" y="6280949"/>
+            <a:ext cx="418704" cy="369332"/>
           </a:xfrm>
           <a:prstGeom prst="rect">
             <a:avLst/>
@@ -6320,7 +6320,7 @@
                   <a:schemeClr val="bg1"/>
                 </a:solidFill>
               </a:rPr>
-              <a:t>1</a:t>
+              <a:t>10</a:t>
             </a:r>
           </a:p>
         </p:txBody>
@@ -6692,8 +6692,8 @@
         </p:nvSpPr>
         <p:spPr>
           <a:xfrm>
-            <a:off x="11644828" y="6286712"/>
-            <a:ext cx="301686" cy="369332"/>
+            <a:off x="11574734" y="6286712"/>
+            <a:ext cx="418704" cy="369332"/>
           </a:xfrm>
           <a:prstGeom prst="rect">
             <a:avLst/>
@@ -6712,7 +6712,7 @@
                   <a:schemeClr val="bg1"/>
                 </a:solidFill>
               </a:rPr>
-              <a:t>1</a:t>
+              <a:t>11</a:t>
             </a:r>
           </a:p>
         </p:txBody>
@@ -8053,8 +8053,8 @@
         </p:nvSpPr>
         <p:spPr>
           <a:xfrm>
-            <a:off x="11644828" y="6286712"/>
-            <a:ext cx="301686" cy="369332"/>
+            <a:off x="11579333" y="6271250"/>
+            <a:ext cx="418704" cy="369332"/>
           </a:xfrm>
           <a:prstGeom prst="rect">
             <a:avLst/>
@@ -8073,7 +8073,7 @@
                   <a:schemeClr val="bg1"/>
                 </a:solidFill>
               </a:rPr>
-              <a:t>1</a:t>
+              <a:t>12</a:t>
             </a:r>
           </a:p>
         </p:txBody>
@@ -8408,8 +8408,8 @@
         </p:nvSpPr>
         <p:spPr>
           <a:xfrm>
-            <a:off x="11644828" y="6286712"/>
-            <a:ext cx="301686" cy="369332"/>
+            <a:off x="11583932" y="6261770"/>
+            <a:ext cx="418704" cy="369332"/>
           </a:xfrm>
           <a:prstGeom prst="rect">
             <a:avLst/>
@@ -8428,7 +8428,7 @@
                   <a:schemeClr val="bg1"/>
                 </a:solidFill>
               </a:rPr>
-              <a:t>1</a:t>
+              <a:t>13</a:t>
             </a:r>
           </a:p>
         </p:txBody>
@@ -8763,8 +8763,8 @@
         </p:nvSpPr>
         <p:spPr>
           <a:xfrm>
-            <a:off x="11644828" y="6286712"/>
-            <a:ext cx="301686" cy="369332"/>
+            <a:off x="11583932" y="6286712"/>
+            <a:ext cx="418704" cy="369332"/>
           </a:xfrm>
           <a:prstGeom prst="rect">
             <a:avLst/>
@@ -8783,7 +8783,7 @@
                   <a:schemeClr val="bg1"/>
                 </a:solidFill>
               </a:rPr>
-              <a:t>1</a:t>
+              <a:t>14</a:t>
             </a:r>
           </a:p>
         </p:txBody>
@@ -9118,8 +9118,8 @@
         </p:nvSpPr>
         <p:spPr>
           <a:xfrm>
-            <a:off x="11644828" y="6286712"/>
-            <a:ext cx="301686" cy="369332"/>
+            <a:off x="11583932" y="6281112"/>
+            <a:ext cx="418704" cy="369332"/>
           </a:xfrm>
           <a:prstGeom prst="rect">
             <a:avLst/>
@@ -9138,7 +9138,7 @@
                   <a:schemeClr val="bg1"/>
                 </a:solidFill>
               </a:rPr>
-              <a:t>1</a:t>
+              <a:t>15</a:t>
             </a:r>
           </a:p>
         </p:txBody>
@@ -10473,8 +10473,8 @@
         </p:nvSpPr>
         <p:spPr>
           <a:xfrm>
-            <a:off x="11644828" y="6286712"/>
-            <a:ext cx="301686" cy="369332"/>
+            <a:off x="11581768" y="6286712"/>
+            <a:ext cx="418704" cy="369332"/>
           </a:xfrm>
           <a:prstGeom prst="rect">
             <a:avLst/>
@@ -10493,7 +10493,7 @@
                   <a:schemeClr val="bg1"/>
                 </a:solidFill>
               </a:rPr>
-              <a:t>1</a:t>
+              <a:t>16</a:t>
             </a:r>
           </a:p>
         </p:txBody>
@@ -10982,8 +10982,8 @@
         </p:nvSpPr>
         <p:spPr>
           <a:xfrm>
-            <a:off x="11644828" y="6286712"/>
-            <a:ext cx="301686" cy="369332"/>
+            <a:off x="11583932" y="6286712"/>
+            <a:ext cx="418704" cy="369332"/>
           </a:xfrm>
           <a:prstGeom prst="rect">
             <a:avLst/>
@@ -11002,7 +11002,7 @@
                   <a:schemeClr val="bg1"/>
                 </a:solidFill>
               </a:rPr>
-              <a:t>1</a:t>
+              <a:t>17</a:t>
             </a:r>
           </a:p>
         </p:txBody>
@@ -11316,8 +11316,8 @@
         </p:nvSpPr>
         <p:spPr>
           <a:xfrm>
-            <a:off x="11644828" y="6286712"/>
-            <a:ext cx="301686" cy="369332"/>
+            <a:off x="11583932" y="6286712"/>
+            <a:ext cx="418704" cy="369332"/>
           </a:xfrm>
           <a:prstGeom prst="rect">
             <a:avLst/>
@@ -11336,7 +11336,7 @@
                   <a:schemeClr val="bg1"/>
                 </a:solidFill>
               </a:rPr>
-              <a:t>1</a:t>
+              <a:t>18</a:t>
             </a:r>
           </a:p>
         </p:txBody>
@@ -12323,8 +12323,8 @@
         </p:nvSpPr>
         <p:spPr>
           <a:xfrm>
-            <a:off x="11644828" y="6286712"/>
-            <a:ext cx="301686" cy="369332"/>
+            <a:off x="11583932" y="6286712"/>
+            <a:ext cx="418704" cy="369332"/>
           </a:xfrm>
           <a:prstGeom prst="rect">
             <a:avLst/>
@@ -12343,7 +12343,7 @@
                   <a:schemeClr val="bg1"/>
                 </a:solidFill>
               </a:rPr>
-              <a:t>1</a:t>
+              <a:t>19</a:t>
             </a:r>
           </a:p>
         </p:txBody>
@@ -12682,8 +12682,8 @@
         </p:nvSpPr>
         <p:spPr>
           <a:xfrm>
-            <a:off x="11644828" y="6286712"/>
-            <a:ext cx="301686" cy="369332"/>
+            <a:off x="11583932" y="6287167"/>
+            <a:ext cx="418704" cy="369332"/>
           </a:xfrm>
           <a:prstGeom prst="rect">
             <a:avLst/>
@@ -12702,7 +12702,7 @@
                   <a:schemeClr val="bg1"/>
                 </a:solidFill>
               </a:rPr>
-              <a:t>1</a:t>
+              <a:t>20</a:t>
             </a:r>
           </a:p>
         </p:txBody>
@@ -13081,8 +13081,8 @@
         </p:nvSpPr>
         <p:spPr>
           <a:xfrm>
-            <a:off x="11644828" y="6286712"/>
-            <a:ext cx="301686" cy="369332"/>
+            <a:off x="11583932" y="6286712"/>
+            <a:ext cx="418704" cy="369332"/>
           </a:xfrm>
           <a:prstGeom prst="rect">
             <a:avLst/>
@@ -13101,7 +13101,7 @@
                   <a:schemeClr val="bg1"/>
                 </a:solidFill>
               </a:rPr>
-              <a:t>1</a:t>
+              <a:t>21</a:t>
             </a:r>
           </a:p>
         </p:txBody>
@@ -13589,8 +13589,8 @@
         </p:nvSpPr>
         <p:spPr>
           <a:xfrm>
-            <a:off x="11644828" y="6286712"/>
-            <a:ext cx="301686" cy="369332"/>
+            <a:off x="11583932" y="6286712"/>
+            <a:ext cx="418704" cy="369332"/>
           </a:xfrm>
           <a:prstGeom prst="rect">
             <a:avLst/>
@@ -13609,7 +13609,7 @@
                   <a:schemeClr val="bg1"/>
                 </a:solidFill>
               </a:rPr>
-              <a:t>1</a:t>
+              <a:t>22</a:t>
             </a:r>
           </a:p>
         </p:txBody>
@@ -15127,7 +15127,7 @@
                   <a:schemeClr val="bg1"/>
                 </a:solidFill>
               </a:rPr>
-              <a:t>1</a:t>
+              <a:t>2</a:t>
             </a:r>
           </a:p>
         </p:txBody>
@@ -16494,7 +16494,7 @@
                   <a:schemeClr val="bg1"/>
                 </a:solidFill>
               </a:rPr>
-              <a:t>1</a:t>
+              <a:t>3</a:t>
             </a:r>
           </a:p>
         </p:txBody>
@@ -17184,7 +17184,7 @@
                   <a:schemeClr val="bg1"/>
                 </a:solidFill>
               </a:rPr>
-              <a:t>1</a:t>
+              <a:t>4</a:t>
             </a:r>
           </a:p>
         </p:txBody>
@@ -18557,7 +18557,7 @@
                   <a:schemeClr val="bg1"/>
                 </a:solidFill>
               </a:rPr>
-              <a:t>1</a:t>
+              <a:t>5</a:t>
             </a:r>
           </a:p>
         </p:txBody>
@@ -19284,7 +19284,7 @@
                   <a:schemeClr val="bg1"/>
                 </a:solidFill>
               </a:rPr>
-              <a:t>1</a:t>
+              <a:t>6</a:t>
             </a:r>
           </a:p>
         </p:txBody>
@@ -19911,7 +19911,7 @@
                   <a:schemeClr val="bg1"/>
                 </a:solidFill>
               </a:rPr>
-              <a:t>1</a:t>
+              <a:t>7</a:t>
             </a:r>
           </a:p>
         </p:txBody>
@@ -20587,7 +20587,7 @@
                   <a:schemeClr val="bg1"/>
                 </a:solidFill>
               </a:rPr>
-              <a:t>1</a:t>
+              <a:t>8</a:t>
             </a:r>
           </a:p>
         </p:txBody>

</xml_diff>